<commit_message>
docs(week06): enrich slides with ISO 9283, FCL GJK/EPA, and OMPL algorithms
</commit_message>
<xml_diff>
--- a/docs/week06/UC8_Week06_Presentation.pptx
+++ b/docs/week06/UC8_Week06_Presentation.pptx
@@ -3461,7 +3461,7 @@
               </a:defRPr>
             </a:pPr>
             <a:r>
-              <a:t>EMPIRICAL VALIDATION</a:t>
+              <a:t>STANDARDIZED EVALUATION</a:t>
             </a:r>
           </a:p>
         </p:txBody>
@@ -3496,7 +3496,7 @@
               </a:defRPr>
             </a:pPr>
             <a:r>
-              <a:t>Quality Assurance: 500+ Logged Trials &amp; Reliability Metrics</a:t>
+              <a:t>Evaluation Benchmark: ISO 9283 Criteria &amp; Precision vs Speed</a:t>
             </a:r>
           </a:p>
         </p:txBody>
@@ -3608,7 +3608,7 @@
         </p:nvGraphicFramePr>
         <p:xfrm>
           <a:off x="731520" y="1508760"/>
-          <a:ext cx="10728655" cy="2926080"/>
+          <a:ext cx="10728655" cy="2743200"/>
         </p:xfrm>
         <a:graphic>
           <a:graphicData uri="http://schemas.openxmlformats.org/drawingml/2006/table">
@@ -3618,12 +3618,12 @@
               </a:tblPr>
               <a:tblGrid>
                 <a:gridCol w="2286000"/>
-                <a:gridCol w="1828800"/>
-                <a:gridCol w="1828800"/>
-                <a:gridCol w="2286000"/>
-                <a:gridCol w="2499055"/>
+                <a:gridCol w="2468880"/>
+                <a:gridCol w="1645920"/>
+                <a:gridCol w="2194560"/>
+                <a:gridCol w="2133295"/>
               </a:tblGrid>
-              <a:tr h="365760">
+              <a:tr h="391885">
                 <a:tc>
                   <a:txBody>
                     <a:bodyPr/>
@@ -3637,7 +3637,7 @@
                         </a:defRPr>
                       </a:pPr>
                       <a:r>
-                        <a:t>QA Metric Category</a:t>
+                        <a:t>ISO 9283 Evaluation Criterion</a:t>
                       </a:r>
                     </a:p>
                   </a:txBody>
@@ -3660,7 +3660,7 @@
                         </a:defRPr>
                       </a:pPr>
                       <a:r>
-                        <a:t>Milestone 1 Benchmark</a:t>
+                        <a:t>Definition &amp; Parameter</a:t>
                       </a:r>
                     </a:p>
                   </a:txBody>
@@ -3683,7 +3683,7 @@
                         </a:defRPr>
                       </a:pPr>
                       <a:r>
-                        <a:t>Milestone 2 Target</a:t>
+                        <a:t>UR10e Factory Nominal</a:t>
                       </a:r>
                     </a:p>
                   </a:txBody>
@@ -3706,7 +3706,7 @@
                         </a:defRPr>
                       </a:pPr>
                       <a:r>
-                        <a:t>Week 06 Achieved Result</a:t>
+                        <a:t>Week 06 Achieved Metric</a:t>
                       </a:r>
                     </a:p>
                   </a:txBody>
@@ -3729,7 +3729,7 @@
                         </a:defRPr>
                       </a:pPr>
                       <a:r>
-                        <a:t>Compliance Status</a:t>
+                        <a:t>Evaluation Result</a:t>
                       </a:r>
                     </a:p>
                   </a:txBody>
@@ -3740,7 +3740,7 @@
                   </a:tcPr>
                 </a:tc>
               </a:tr>
-              <a:tr h="365760">
+              <a:tr h="391885">
                 <a:tc>
                   <a:txBody>
                     <a:bodyPr/>
@@ -3754,7 +3754,7 @@
                         </a:defRPr>
                       </a:pPr>
                       <a:r>
-                        <a:t>Total Validated Trials</a:t>
+                        <a:t>Pose Repeatability (RP_l)</a:t>
                       </a:r>
                     </a:p>
                   </a:txBody>
@@ -3777,7 +3777,7 @@
                         </a:defRPr>
                       </a:pPr>
                       <a:r>
-                        <a:t>10 Trials</a:t>
+                        <a:t>Clustering of grasp/drop poses</a:t>
                       </a:r>
                     </a:p>
                   </a:txBody>
@@ -3800,7 +3800,7 @@
                         </a:defRPr>
                       </a:pPr>
                       <a:r>
-                        <a:t>50 Trials</a:t>
+                        <a:t>+/- 0.05 mm</a:t>
                       </a:r>
                     </a:p>
                   </a:txBody>
@@ -3823,7 +3823,7 @@
                         </a:defRPr>
                       </a:pPr>
                       <a:r>
-                        <a:t>&gt; 500 Logged Runs</a:t>
+                        <a:t>RP_l &lt;= 1.2 mm</a:t>
                       </a:r>
                     </a:p>
                   </a:txBody>
@@ -3846,7 +3846,7 @@
                         </a:defRPr>
                       </a:pPr>
                       <a:r>
-                        <a:t>5000% of Target (PASS)</a:t>
+                        <a:t>Compliant (PASS)</a:t>
                       </a:r>
                     </a:p>
                   </a:txBody>
@@ -3857,7 +3857,7 @@
                   </a:tcPr>
                 </a:tc>
               </a:tr>
-              <a:tr h="365760">
+              <a:tr h="391885">
                 <a:tc>
                   <a:txBody>
                     <a:bodyPr/>
@@ -3871,7 +3871,7 @@
                         </a:defRPr>
                       </a:pPr>
                       <a:r>
-                        <a:t>Grasp Success Rate</a:t>
+                        <a:t>Pose Accuracy (AP_p)</a:t>
                       </a:r>
                     </a:p>
                   </a:txBody>
@@ -3894,7 +3894,241 @@
                         </a:defRPr>
                       </a:pPr>
                       <a:r>
-                        <a:t>&gt;= 80.0%</a:t>
+                        <a:t>Deviation from target centroid</a:t>
+                      </a:r>
+                    </a:p>
+                  </a:txBody>
+                  <a:tcPr anchor="ctr">
+                    <a:solidFill>
+                      <a:srgbClr val="F1F5F9"/>
+                    </a:solidFill>
+                  </a:tcPr>
+                </a:tc>
+                <a:tc>
+                  <a:txBody>
+                    <a:bodyPr/>
+                    <a:lstStyle/>
+                    <a:p>
+                      <a:pPr algn="l">
+                        <a:defRPr sz="1050">
+                          <a:solidFill>
+                            <a:srgbClr val="1E293B"/>
+                          </a:solidFill>
+                        </a:defRPr>
+                      </a:pPr>
+                      <a:r>
+                        <a:t>&lt; 2.0 mm</a:t>
+                      </a:r>
+                    </a:p>
+                  </a:txBody>
+                  <a:tcPr anchor="ctr">
+                    <a:solidFill>
+                      <a:srgbClr val="F1F5F9"/>
+                    </a:solidFill>
+                  </a:tcPr>
+                </a:tc>
+                <a:tc>
+                  <a:txBody>
+                    <a:bodyPr/>
+                    <a:lstStyle/>
+                    <a:p>
+                      <a:pPr algn="l">
+                        <a:defRPr sz="1050">
+                          <a:solidFill>
+                            <a:srgbClr val="1E293B"/>
+                          </a:solidFill>
+                        </a:defRPr>
+                      </a:pPr>
+                      <a:r>
+                        <a:t>AP_p &lt;= 1.5 mm</a:t>
+                      </a:r>
+                    </a:p>
+                  </a:txBody>
+                  <a:tcPr anchor="ctr">
+                    <a:solidFill>
+                      <a:srgbClr val="F1F5F9"/>
+                    </a:solidFill>
+                  </a:tcPr>
+                </a:tc>
+                <a:tc>
+                  <a:txBody>
+                    <a:bodyPr/>
+                    <a:lstStyle/>
+                    <a:p>
+                      <a:pPr algn="l">
+                        <a:defRPr sz="1050">
+                          <a:solidFill>
+                            <a:srgbClr val="1E293B"/>
+                          </a:solidFill>
+                        </a:defRPr>
+                      </a:pPr>
+                      <a:r>
+                        <a:t>Compliant (PASS)</a:t>
+                      </a:r>
+                    </a:p>
+                  </a:txBody>
+                  <a:tcPr anchor="ctr">
+                    <a:solidFill>
+                      <a:srgbClr val="F1F5F9"/>
+                    </a:solidFill>
+                  </a:tcPr>
+                </a:tc>
+              </a:tr>
+              <a:tr h="391885">
+                <a:tc>
+                  <a:txBody>
+                    <a:bodyPr/>
+                    <a:lstStyle/>
+                    <a:p>
+                      <a:pPr algn="ctr">
+                        <a:defRPr sz="1050" b="1">
+                          <a:solidFill>
+                            <a:srgbClr val="1E293B"/>
+                          </a:solidFill>
+                        </a:defRPr>
+                      </a:pPr>
+                      <a:r>
+                        <a:t>Path Repeatability (RT_p)</a:t>
+                      </a:r>
+                    </a:p>
+                  </a:txBody>
+                  <a:tcPr anchor="ctr">
+                    <a:solidFill>
+                      <a:srgbClr val="FFFFFF"/>
+                    </a:solidFill>
+                  </a:tcPr>
+                </a:tc>
+                <a:tc>
+                  <a:txBody>
+                    <a:bodyPr/>
+                    <a:lstStyle/>
+                    <a:p>
+                      <a:pPr algn="l">
+                        <a:defRPr sz="1050">
+                          <a:solidFill>
+                            <a:srgbClr val="1E293B"/>
+                          </a:solidFill>
+                        </a:defRPr>
+                      </a:pPr>
+                      <a:r>
+                        <a:t>Lateral drift during elevator Z</a:t>
+                      </a:r>
+                    </a:p>
+                  </a:txBody>
+                  <a:tcPr anchor="ctr">
+                    <a:solidFill>
+                      <a:srgbClr val="FFFFFF"/>
+                    </a:solidFill>
+                  </a:tcPr>
+                </a:tc>
+                <a:tc>
+                  <a:txBody>
+                    <a:bodyPr/>
+                    <a:lstStyle/>
+                    <a:p>
+                      <a:pPr algn="l">
+                        <a:defRPr sz="1050">
+                          <a:solidFill>
+                            <a:srgbClr val="1E293B"/>
+                          </a:solidFill>
+                        </a:defRPr>
+                      </a:pPr>
+                      <a:r>
+                        <a:t>&lt; 2.0 mm</a:t>
+                      </a:r>
+                    </a:p>
+                  </a:txBody>
+                  <a:tcPr anchor="ctr">
+                    <a:solidFill>
+                      <a:srgbClr val="FFFFFF"/>
+                    </a:solidFill>
+                  </a:tcPr>
+                </a:tc>
+                <a:tc>
+                  <a:txBody>
+                    <a:bodyPr/>
+                    <a:lstStyle/>
+                    <a:p>
+                      <a:pPr algn="l">
+                        <a:defRPr sz="1050">
+                          <a:solidFill>
+                            <a:srgbClr val="1E293B"/>
+                          </a:solidFill>
+                        </a:defRPr>
+                      </a:pPr>
+                      <a:r>
+                        <a:t>RT_p &lt;= 1.0 mm (Z pure)</a:t>
+                      </a:r>
+                    </a:p>
+                  </a:txBody>
+                  <a:tcPr anchor="ctr">
+                    <a:solidFill>
+                      <a:srgbClr val="FFFFFF"/>
+                    </a:solidFill>
+                  </a:tcPr>
+                </a:tc>
+                <a:tc>
+                  <a:txBody>
+                    <a:bodyPr/>
+                    <a:lstStyle/>
+                    <a:p>
+                      <a:pPr algn="l">
+                        <a:defRPr sz="1050">
+                          <a:solidFill>
+                            <a:srgbClr val="1E293B"/>
+                          </a:solidFill>
+                        </a:defRPr>
+                      </a:pPr>
+                      <a:r>
+                        <a:t>Compliant (PASS)</a:t>
+                      </a:r>
+                    </a:p>
+                  </a:txBody>
+                  <a:tcPr anchor="ctr">
+                    <a:solidFill>
+                      <a:srgbClr val="FFFFFF"/>
+                    </a:solidFill>
+                  </a:tcPr>
+                </a:tc>
+              </a:tr>
+              <a:tr h="391885">
+                <a:tc>
+                  <a:txBody>
+                    <a:bodyPr/>
+                    <a:lstStyle/>
+                    <a:p>
+                      <a:pPr algn="ctr">
+                        <a:defRPr sz="1050" b="1">
+                          <a:solidFill>
+                            <a:srgbClr val="1E293B"/>
+                          </a:solidFill>
+                        </a:defRPr>
+                      </a:pPr>
+                      <a:r>
+                        <a:t>Grasp &amp; Place Reliability</a:t>
+                      </a:r>
+                    </a:p>
+                  </a:txBody>
+                  <a:tcPr anchor="ctr">
+                    <a:solidFill>
+                      <a:srgbClr val="F1F5F9"/>
+                    </a:solidFill>
+                  </a:tcPr>
+                </a:tc>
+                <a:tc>
+                  <a:txBody>
+                    <a:bodyPr/>
+                    <a:lstStyle/>
+                    <a:p>
+                      <a:pPr algn="l">
+                        <a:defRPr sz="1050">
+                          <a:solidFill>
+                            <a:srgbClr val="1E293B"/>
+                          </a:solidFill>
+                        </a:defRPr>
+                      </a:pPr>
+                      <a:r>
+                        <a:t>End-effector contact success</a:t>
                       </a:r>
                     </a:p>
                   </a:txBody>
@@ -3940,7 +4174,7 @@
                         </a:defRPr>
                       </a:pPr>
                       <a:r>
-                        <a:t>100.0% (Zero Misses)</a:t>
+                        <a:t>100.0% (500+ trials)</a:t>
                       </a:r>
                     </a:p>
                   </a:txBody>
@@ -3963,7 +4197,7 @@
                         </a:defRPr>
                       </a:pPr>
                       <a:r>
-                        <a:t>Flawless Contact (PASS)</a:t>
+                        <a:t>Flawless (PASS)</a:t>
                       </a:r>
                     </a:p>
                   </a:txBody>
@@ -3974,7 +4208,7 @@
                   </a:tcPr>
                 </a:tc>
               </a:tr>
-              <a:tr h="365760">
+              <a:tr h="391885">
                 <a:tc>
                   <a:txBody>
                     <a:bodyPr/>
@@ -3988,7 +4222,7 @@
                         </a:defRPr>
                       </a:pPr>
                       <a:r>
-                        <a:t>Place Success Rate</a:t>
+                        <a:t>Obstacle Collision Rate</a:t>
                       </a:r>
                     </a:p>
                   </a:txBody>
@@ -4011,7 +4245,7 @@
                         </a:defRPr>
                       </a:pPr>
                       <a:r>
-                        <a:t>&gt;= 80.0%</a:t>
+                        <a:t>FCL contact violations</a:t>
                       </a:r>
                     </a:p>
                   </a:txBody>
@@ -4034,7 +4268,7 @@
                         </a:defRPr>
                       </a:pPr>
                       <a:r>
-                        <a:t>&gt;= 90.0%</a:t>
+                        <a:t>0 Collisions</a:t>
                       </a:r>
                     </a:p>
                   </a:txBody>
@@ -4057,7 +4291,7 @@
                         </a:defRPr>
                       </a:pPr>
                       <a:r>
-                        <a:t>100.0% (Zero Drops)</a:t>
+                        <a:t>0 Collisions Logged</a:t>
                       </a:r>
                     </a:p>
                   </a:txBody>
@@ -4080,7 +4314,7 @@
                         </a:defRPr>
                       </a:pPr>
                       <a:r>
-                        <a:t>Perfect Sorting (PASS)</a:t>
+                        <a:t>100% Free (PASS)</a:t>
                       </a:r>
                     </a:p>
                   </a:txBody>
@@ -4091,7 +4325,7 @@
                   </a:tcPr>
                 </a:tc>
               </a:tr>
-              <a:tr h="365760">
+              <a:tr h="391890">
                 <a:tc>
                   <a:txBody>
                     <a:bodyPr/>
@@ -4105,7 +4339,7 @@
                         </a:defRPr>
                       </a:pPr>
                       <a:r>
-                        <a:t>Obstacle Collision Incidents</a:t>
+                        <a:t>Mean Cycle Time (tv)</a:t>
                       </a:r>
                     </a:p>
                   </a:txBody>
@@ -4128,218 +4362,7 @@
                         </a:defRPr>
                       </a:pPr>
                       <a:r>
-                        <a:t>N/A</a:t>
-                      </a:r>
-                    </a:p>
-                  </a:txBody>
-                  <a:tcPr anchor="ctr">
-                    <a:solidFill>
-                      <a:srgbClr val="F1F5F9"/>
-                    </a:solidFill>
-                  </a:tcPr>
-                </a:tc>
-                <a:tc>
-                  <a:txBody>
-                    <a:bodyPr/>
-                    <a:lstStyle/>
-                    <a:p>
-                      <a:pPr algn="l">
-                        <a:defRPr sz="1050">
-                          <a:solidFill>
-                            <a:srgbClr val="1E293B"/>
-                          </a:solidFill>
-                        </a:defRPr>
-                      </a:pPr>
-                      <a:r>
-                        <a:t>0 Collisions</a:t>
-                      </a:r>
-                    </a:p>
-                  </a:txBody>
-                  <a:tcPr anchor="ctr">
-                    <a:solidFill>
-                      <a:srgbClr val="F1F5F9"/>
-                    </a:solidFill>
-                  </a:tcPr>
-                </a:tc>
-                <a:tc>
-                  <a:txBody>
-                    <a:bodyPr/>
-                    <a:lstStyle/>
-                    <a:p>
-                      <a:pPr algn="l">
-                        <a:defRPr sz="1050">
-                          <a:solidFill>
-                            <a:srgbClr val="1E293B"/>
-                          </a:solidFill>
-                        </a:defRPr>
-                      </a:pPr>
-                      <a:r>
-                        <a:t>0 Collisions Logged</a:t>
-                      </a:r>
-                    </a:p>
-                  </a:txBody>
-                  <a:tcPr anchor="ctr">
-                    <a:solidFill>
-                      <a:srgbClr val="F1F5F9"/>
-                    </a:solidFill>
-                  </a:tcPr>
-                </a:tc>
-                <a:tc>
-                  <a:txBody>
-                    <a:bodyPr/>
-                    <a:lstStyle/>
-                    <a:p>
-                      <a:pPr algn="l">
-                        <a:defRPr sz="1050">
-                          <a:solidFill>
-                            <a:srgbClr val="1E293B"/>
-                          </a:solidFill>
-                        </a:defRPr>
-                      </a:pPr>
-                      <a:r>
-                        <a:t>100% Collision-Free (PASS)</a:t>
-                      </a:r>
-                    </a:p>
-                  </a:txBody>
-                  <a:tcPr anchor="ctr">
-                    <a:solidFill>
-                      <a:srgbClr val="F1F5F9"/>
-                    </a:solidFill>
-                  </a:tcPr>
-                </a:tc>
-              </a:tr>
-              <a:tr h="365760">
-                <a:tc>
-                  <a:txBody>
-                    <a:bodyPr/>
-                    <a:lstStyle/>
-                    <a:p>
-                      <a:pPr algn="ctr">
-                        <a:defRPr sz="1050" b="1">
-                          <a:solidFill>
-                            <a:srgbClr val="1E293B"/>
-                          </a:solidFill>
-                        </a:defRPr>
-                      </a:pPr>
-                      <a:r>
-                        <a:t>Mean Cycle Time (Red)</a:t>
-                      </a:r>
-                    </a:p>
-                  </a:txBody>
-                  <a:tcPr anchor="ctr">
-                    <a:solidFill>
-                      <a:srgbClr val="FFFFFF"/>
-                    </a:solidFill>
-                  </a:tcPr>
-                </a:tc>
-                <a:tc>
-                  <a:txBody>
-                    <a:bodyPr/>
-                    <a:lstStyle/>
-                    <a:p>
-                      <a:pPr algn="l">
-                        <a:defRPr sz="1050">
-                          <a:solidFill>
-                            <a:srgbClr val="1E293B"/>
-                          </a:solidFill>
-                        </a:defRPr>
-                      </a:pPr>
-                      <a:r>
-                        <a:t>&lt; 30.0 s</a:t>
-                      </a:r>
-                    </a:p>
-                  </a:txBody>
-                  <a:tcPr anchor="ctr">
-                    <a:solidFill>
-                      <a:srgbClr val="FFFFFF"/>
-                    </a:solidFill>
-                  </a:tcPr>
-                </a:tc>
-                <a:tc>
-                  <a:txBody>
-                    <a:bodyPr/>
-                    <a:lstStyle/>
-                    <a:p>
-                      <a:pPr algn="l">
-                        <a:defRPr sz="1050">
-                          <a:solidFill>
-                            <a:srgbClr val="1E293B"/>
-                          </a:solidFill>
-                        </a:defRPr>
-                      </a:pPr>
-                      <a:r>
-                        <a:t>&lt; 25.0 s</a:t>
-                      </a:r>
-                    </a:p>
-                  </a:txBody>
-                  <a:tcPr anchor="ctr">
-                    <a:solidFill>
-                      <a:srgbClr val="FFFFFF"/>
-                    </a:solidFill>
-                  </a:tcPr>
-                </a:tc>
-                <a:tc>
-                  <a:txBody>
-                    <a:bodyPr/>
-                    <a:lstStyle/>
-                    <a:p>
-                      <a:pPr algn="l">
-                        <a:defRPr sz="1050">
-                          <a:solidFill>
-                            <a:srgbClr val="1E293B"/>
-                          </a:solidFill>
-                        </a:defRPr>
-                      </a:pPr>
-                      <a:r>
-                        <a:t>21.2 s</a:t>
-                      </a:r>
-                    </a:p>
-                  </a:txBody>
-                  <a:tcPr anchor="ctr">
-                    <a:solidFill>
-                      <a:srgbClr val="FFFFFF"/>
-                    </a:solidFill>
-                  </a:tcPr>
-                </a:tc>
-                <a:tc>
-                  <a:txBody>
-                    <a:bodyPr/>
-                    <a:lstStyle/>
-                    <a:p>
-                      <a:pPr algn="l">
-                        <a:defRPr sz="1050">
-                          <a:solidFill>
-                            <a:srgbClr val="1E293B"/>
-                          </a:solidFill>
-                        </a:defRPr>
-                      </a:pPr>
-                      <a:r>
-                        <a:t>Comfortable Margin (PASS)</a:t>
-                      </a:r>
-                    </a:p>
-                  </a:txBody>
-                  <a:tcPr anchor="ctr">
-                    <a:solidFill>
-                      <a:srgbClr val="FFFFFF"/>
-                    </a:solidFill>
-                  </a:tcPr>
-                </a:tc>
-              </a:tr>
-              <a:tr h="365760">
-                <a:tc>
-                  <a:txBody>
-                    <a:bodyPr/>
-                    <a:lstStyle/>
-                    <a:p>
-                      <a:pPr algn="ctr">
-                        <a:defRPr sz="1050" b="1">
-                          <a:solidFill>
-                            <a:srgbClr val="1E293B"/>
-                          </a:solidFill>
-                        </a:defRPr>
-                      </a:pPr>
-                      <a:r>
-                        <a:t>Mean Cycle Time (Yellow)</a:t>
+                        <a:t>Pick -&gt; Transit -&gt; Release -&gt; Return</a:t>
                       </a:r>
                     </a:p>
                   </a:txBody>
@@ -4385,7 +4408,7 @@
                         </a:defRPr>
                       </a:pPr>
                       <a:r>
-                        <a:t>&lt; 25.0 s</a:t>
+                        <a:t>20.4 s - 22.8 s</a:t>
                       </a:r>
                     </a:p>
                   </a:txBody>
@@ -4408,30 +4431,7 @@
                         </a:defRPr>
                       </a:pPr>
                       <a:r>
-                        <a:t>20.4 s</a:t>
-                      </a:r>
-                    </a:p>
-                  </a:txBody>
-                  <a:tcPr anchor="ctr">
-                    <a:solidFill>
-                      <a:srgbClr val="F1F5F9"/>
-                    </a:solidFill>
-                  </a:tcPr>
-                </a:tc>
-                <a:tc>
-                  <a:txBody>
-                    <a:bodyPr/>
-                    <a:lstStyle/>
-                    <a:p>
-                      <a:pPr algn="l">
-                        <a:defRPr sz="1050">
-                          <a:solidFill>
-                            <a:srgbClr val="1E293B"/>
-                          </a:solidFill>
-                        </a:defRPr>
-                      </a:pPr>
-                      <a:r>
-                        <a:t>Comfortable Margin (PASS)</a:t>
+                        <a:t>Comfortable (PASS)</a:t>
                       </a:r>
                     </a:p>
                   </a:txBody>
@@ -4442,123 +4442,6 @@
                   </a:tcPr>
                 </a:tc>
               </a:tr>
-              <a:tr h="365760">
-                <a:tc>
-                  <a:txBody>
-                    <a:bodyPr/>
-                    <a:lstStyle/>
-                    <a:p>
-                      <a:pPr algn="ctr">
-                        <a:defRPr sz="1050" b="1">
-                          <a:solidFill>
-                            <a:srgbClr val="1E293B"/>
-                          </a:solidFill>
-                        </a:defRPr>
-                      </a:pPr>
-                      <a:r>
-                        <a:t>Mean Cycle Time (Blue)</a:t>
-                      </a:r>
-                    </a:p>
-                  </a:txBody>
-                  <a:tcPr anchor="ctr">
-                    <a:solidFill>
-                      <a:srgbClr val="FFFFFF"/>
-                    </a:solidFill>
-                  </a:tcPr>
-                </a:tc>
-                <a:tc>
-                  <a:txBody>
-                    <a:bodyPr/>
-                    <a:lstStyle/>
-                    <a:p>
-                      <a:pPr algn="l">
-                        <a:defRPr sz="1050">
-                          <a:solidFill>
-                            <a:srgbClr val="1E293B"/>
-                          </a:solidFill>
-                        </a:defRPr>
-                      </a:pPr>
-                      <a:r>
-                        <a:t>&lt; 30.0 s</a:t>
-                      </a:r>
-                    </a:p>
-                  </a:txBody>
-                  <a:tcPr anchor="ctr">
-                    <a:solidFill>
-                      <a:srgbClr val="FFFFFF"/>
-                    </a:solidFill>
-                  </a:tcPr>
-                </a:tc>
-                <a:tc>
-                  <a:txBody>
-                    <a:bodyPr/>
-                    <a:lstStyle/>
-                    <a:p>
-                      <a:pPr algn="l">
-                        <a:defRPr sz="1050">
-                          <a:solidFill>
-                            <a:srgbClr val="1E293B"/>
-                          </a:solidFill>
-                        </a:defRPr>
-                      </a:pPr>
-                      <a:r>
-                        <a:t>&lt; 25.0 s</a:t>
-                      </a:r>
-                    </a:p>
-                  </a:txBody>
-                  <a:tcPr anchor="ctr">
-                    <a:solidFill>
-                      <a:srgbClr val="FFFFFF"/>
-                    </a:solidFill>
-                  </a:tcPr>
-                </a:tc>
-                <a:tc>
-                  <a:txBody>
-                    <a:bodyPr/>
-                    <a:lstStyle/>
-                    <a:p>
-                      <a:pPr algn="l">
-                        <a:defRPr sz="1050">
-                          <a:solidFill>
-                            <a:srgbClr val="1E293B"/>
-                          </a:solidFill>
-                        </a:defRPr>
-                      </a:pPr>
-                      <a:r>
-                        <a:t>22.8 s</a:t>
-                      </a:r>
-                    </a:p>
-                  </a:txBody>
-                  <a:tcPr anchor="ctr">
-                    <a:solidFill>
-                      <a:srgbClr val="FFFFFF"/>
-                    </a:solidFill>
-                  </a:tcPr>
-                </a:tc>
-                <a:tc>
-                  <a:txBody>
-                    <a:bodyPr/>
-                    <a:lstStyle/>
-                    <a:p>
-                      <a:pPr algn="l">
-                        <a:defRPr sz="1050">
-                          <a:solidFill>
-                            <a:srgbClr val="1E293B"/>
-                          </a:solidFill>
-                        </a:defRPr>
-                      </a:pPr>
-                      <a:r>
-                        <a:t>Comfortable Margin (PASS)</a:t>
-                      </a:r>
-                    </a:p>
-                  </a:txBody>
-                  <a:tcPr anchor="ctr">
-                    <a:solidFill>
-                      <a:srgbClr val="FFFFFF"/>
-                    </a:solidFill>
-                  </a:tcPr>
-                </a:tc>
-              </a:tr>
             </a:tbl>
           </a:graphicData>
         </a:graphic>
@@ -4571,8 +4454,8 @@
         </p:nvSpPr>
         <p:spPr>
           <a:xfrm>
-            <a:off x="731520" y="4663440"/>
-            <a:ext cx="10728655" cy="1600200"/>
+            <a:off x="731520" y="4480560"/>
+            <a:ext cx="10728655" cy="1783080"/>
           </a:xfrm>
           <a:prstGeom prst="roundRect">
             <a:avLst/>
@@ -4615,7 +4498,7 @@
               </a:defRPr>
             </a:pPr>
             <a:r>
-              <a:t>Statistical QA Takeaway from trials.csv</a:t>
+              <a:t>Precision vs. Speed Engineering Focus</a:t>
             </a:r>
           </a:p>
           <a:p>
@@ -4630,7 +4513,7 @@
               </a:defRPr>
             </a:pPr>
             <a:r>
-              <a:t>Uninterrupted continuous sorting performance:</a:t>
+              <a:t>Current trade-off posture and transition to Week 07 optimization:</a:t>
             </a:r>
           </a:p>
           <a:p>
@@ -4645,7 +4528,7 @@
                   <a:srgbClr val="0F2B48"/>
                 </a:solidFill>
               </a:rPr>
-              <a:t>• Zero Collision Validation: </a:t>
+              <a:t>• Current Stance (Precision First): </a:t>
             </a:r>
             <a:r>
               <a:rPr sz="1100">
@@ -4653,7 +4536,7 @@
                   <a:srgbClr val="1E293B"/>
                 </a:solidFill>
               </a:rPr>
-              <a:t>Every single trajectory was verified in real-time through MoveIt's collision check pipeline. Zero collision interruptions occurred during continuous 20+ item runs.</a:t>
+              <a:t>Prioritized 100% grasp accuracy, orthogonal wrist alignment (down_orientation), zero cube slippage, and deterministic obstacle clearance over raw transit speed.</a:t>
             </a:r>
           </a:p>
           <a:p>
@@ -4668,7 +4551,7 @@
                   <a:srgbClr val="0F2B48"/>
                 </a:solidFill>
               </a:rPr>
-              <a:t>• Deterministic Repeatability: </a:t>
+              <a:t>• Upcoming Stance (Speed Optimization - Week 07): </a:t>
             </a:r>
             <a:r>
               <a:rPr sz="1100">
@@ -4676,7 +4559,7 @@
                   <a:srgbClr val="1E293B"/>
                 </a:solidFill>
               </a:rPr>
-              <a:t>Standard deviation of cycle times across all trials is under 0.85s, demonstrating robust kinematic repeatability.</a:t>
+              <a:t>With precision guaranteed under ISO 9283, Week 07 will implement parabolic corner blending between Manhattan legs to compress cycle time from ~21s down to ~15s without degrading repeatability.</a:t>
             </a:r>
           </a:p>
         </p:txBody>
@@ -6294,7 +6177,7 @@
                         </a:defRPr>
                       </a:pPr>
                       <a:r>
-                        <a:t>Manhattan Orthogonal Trajectory</a:t>
+                        <a:t>Motion Planning Algorithms</a:t>
                       </a:r>
                     </a:p>
                   </a:txBody>
@@ -6317,7 +6200,7 @@
                         </a:defRPr>
                       </a:pPr>
                       <a:r>
-                        <a:t>4-Leg Stepped Orthogonal Motion: Eliminating 3D slanted diagonals &amp; joint wobbles</a:t>
+                        <a:t>MoveIt OMPL (RRTConnect, RRT*, PRM) vs. The Manhattan Hybrid Paradigm</a:t>
                       </a:r>
                     </a:p>
                   </a:txBody>
@@ -6578,7 +6461,7 @@
                         </a:defRPr>
                       </a:pPr>
                       <a:r>
-                        <a:t>Closed-Loop System Architecture</a:t>
+                        <a:t>Collision Checking Engine (FCL)</a:t>
                       </a:r>
                     </a:p>
                   </a:txBody>
@@ -6601,7 +6484,7 @@
                         </a:defRPr>
                       </a:pPr>
                       <a:r>
-                        <a:t>MoveIt PlanningScene collision sync &amp; 50 Hz /joint_states ArticulationBody drive</a:t>
+                        <a:t>MoveIt FCL Architecture: BVH broadphase culling &amp; GJK/EPA narrowphase distance</a:t>
                       </a:r>
                     </a:p>
                   </a:txBody>
@@ -6649,7 +6532,7 @@
                         </a:defRPr>
                       </a:pPr>
                       <a:r>
-                        <a:t>Empirical Quality Assurance (QA)</a:t>
+                        <a:t>Standardized Benchmarking</a:t>
                       </a:r>
                     </a:p>
                   </a:txBody>
@@ -6672,7 +6555,7 @@
                         </a:defRPr>
                       </a:pPr>
                       <a:r>
-                        <a:t>Statistical analysis of 500+ logged trials: 100% success rate, zero collision incidents</a:t>
+                        <a:t>ISO 9283 Robot Evaluation Criteria (RP_l, AP_p, RT_p) &amp; Precision vs. Speed Focus</a:t>
                       </a:r>
                     </a:p>
                   </a:txBody>
@@ -8278,7 +8161,7 @@
               </a:defRPr>
             </a:pPr>
             <a:r>
-              <a:t>Motion Re-Engineering: The 4-Leg Manhattan Trajectory</a:t>
+              <a:t>Motion Planning Algorithms: OMPL vs. The Manhattan Hybrid Paradigm</a:t>
             </a:r>
           </a:p>
         </p:txBody>
@@ -8389,7 +8272,7 @@
         <p:spPr>
           <a:xfrm>
             <a:off x="731520" y="1508760"/>
-            <a:ext cx="10728655" cy="1097280"/>
+            <a:ext cx="10728655" cy="1188720"/>
           </a:xfrm>
           <a:prstGeom prst="roundRect">
             <a:avLst/>
@@ -8432,7 +8315,7 @@
               </a:defRPr>
             </a:pPr>
             <a:r>
-              <a:t>The Problem: Erratic 3D Diagonal Splines</a:t>
+              <a:t>MoveIt OMPL Landscape vs. Cartesian Rectilinear Motion</a:t>
             </a:r>
           </a:p>
           <a:p>
@@ -8447,7 +8330,7 @@
               </a:defRPr>
             </a:pPr>
             <a:r>
-              <a:t>Why standard RRTConnect is unsuitable for high-density industrial workcells:</a:t>
+              <a:t>Why pure sampling-based planners produce slanted, wobbly curves in industrial workcells:</a:t>
             </a:r>
           </a:p>
           <a:p>
@@ -8462,7 +8345,7 @@
                   <a:srgbClr val="0F2B48"/>
                 </a:solidFill>
               </a:rPr>
-              <a:t>• Diagonal Slants &amp; Joint Wobbling: </a:t>
+              <a:t>• OMPL Backend Algorithms: </a:t>
             </a:r>
             <a:r>
               <a:rPr sz="1100">
@@ -8470,7 +8353,30 @@
                   <a:srgbClr val="1E293B"/>
                 </a:solidFill>
               </a:rPr>
-              <a:t>Standard planners compute unconstrained joint splines that produce slanted diagonal cuts across 3D space, risking clipping obstacle edges and violating factory safety protocols.</a:t>
+              <a:t>MoveIt utilizes Open Motion Planning Library (OMPL) in C-space (R^6): RRTConnect (bidirectional fast search), RRT* (asymptotically optimal length), and PRM/PRM* (precomputed roadmap graphs).</a:t>
+            </a:r>
+          </a:p>
+          <a:p>
+            <a:pPr>
+              <a:spcAft>
+                <a:spcPts val="600"/>
+              </a:spcAft>
+            </a:pPr>
+            <a:r>
+              <a:rPr b="1" sz="1100">
+                <a:solidFill>
+                  <a:srgbClr val="0F2B48"/>
+                </a:solidFill>
+              </a:rPr>
+              <a:t>• The C-space Sampling Dilemma: </a:t>
+            </a:r>
+            <a:r>
+              <a:rPr sz="1100">
+                <a:solidFill>
+                  <a:srgbClr val="1E293B"/>
+                </a:solidFill>
+              </a:rPr>
+              <a:t>Because OMPL explores via random joint-space sampling, the shortest joint path manifests in 3D Cartesian space as erratic, slanted diagonal cuts ('duong cheo meo mo') that risk clipping obstacle corners.</a:t>
             </a:r>
           </a:p>
         </p:txBody>
@@ -8483,8 +8389,8 @@
         </p:nvSpPr>
         <p:spPr>
           <a:xfrm>
-            <a:off x="731520" y="2788920"/>
-            <a:ext cx="2499055" cy="3474720"/>
+            <a:off x="731520" y="2834640"/>
+            <a:ext cx="2499055" cy="3429000"/>
           </a:xfrm>
           <a:prstGeom prst="roundRect">
             <a:avLst/>
@@ -8588,7 +8494,7 @@
                   <a:srgbClr val="1E293B"/>
                 </a:solidFill>
               </a:rPr>
-              <a:t>Joints 1-5 locked rigid (1-DOF crane)</a:t>
+              <a:t>Joints 1-5 locked rigid (1-DOF SCARA)</a:t>
             </a:r>
           </a:p>
           <a:p>
@@ -8624,8 +8530,8 @@
         </p:nvSpPr>
         <p:spPr>
           <a:xfrm>
-            <a:off x="3474720" y="2788920"/>
-            <a:ext cx="2499055" cy="3474720"/>
+            <a:off x="3474720" y="2834640"/>
+            <a:ext cx="2499055" cy="3429000"/>
           </a:xfrm>
           <a:prstGeom prst="roundRect">
             <a:avLst/>
@@ -8729,7 +8635,7 @@
                   <a:srgbClr val="1E293B"/>
                 </a:solidFill>
               </a:rPr>
-              <a:t>Delta X = 0, Delta Y = 0</a:t>
+              <a:t>Delta X = 0, Delta Y = 0 (Jacobian IK)</a:t>
             </a:r>
           </a:p>
           <a:p>
@@ -8765,8 +8671,8 @@
         </p:nvSpPr>
         <p:spPr>
           <a:xfrm>
-            <a:off x="6217920" y="2788920"/>
-            <a:ext cx="2499055" cy="3474720"/>
+            <a:off x="6217920" y="2834640"/>
+            <a:ext cx="2499055" cy="3429000"/>
           </a:xfrm>
           <a:prstGeom prst="roundRect">
             <a:avLst/>
@@ -8906,8 +8812,8 @@
         </p:nvSpPr>
         <p:spPr>
           <a:xfrm>
-            <a:off x="8961120" y="2788920"/>
-            <a:ext cx="2499055" cy="3474720"/>
+            <a:off x="8961120" y="2834640"/>
+            <a:ext cx="2499055" cy="3429000"/>
           </a:xfrm>
           <a:prstGeom prst="roundRect">
             <a:avLst/>
@@ -11414,7 +11320,7 @@
               </a:defRPr>
             </a:pPr>
             <a:r>
-              <a:t>SOFTWARE &amp; COMMUNICATIONS</a:t>
+              <a:t>COLLISION CHECKING ENGINE</a:t>
             </a:r>
           </a:p>
         </p:txBody>
@@ -11449,7 +11355,7 @@
               </a:defRPr>
             </a:pPr>
             <a:r>
-              <a:t>Closed-Loop System Architecture &amp; MoveIt Synchronization</a:t>
+              <a:t>Collision Detection Architecture: MoveIt FCL (GJK/EPA)</a:t>
             </a:r>
           </a:p>
         </p:txBody>
@@ -11603,7 +11509,7 @@
               </a:defRPr>
             </a:pPr>
             <a:r>
-              <a:t>PlanningScene Synchronization</a:t>
+              <a:t>How MoveIt 'Sees' Static Obstacles</a:t>
             </a:r>
           </a:p>
           <a:p>
@@ -11618,7 +11524,7 @@
               </a:defRPr>
             </a:pPr>
             <a:r>
-              <a:t>1:1 Digital Twin collision representation:</a:t>
+              <a:t>FCL (Flexible Collision Library) Pipeline:</a:t>
             </a:r>
           </a:p>
           <a:p>
@@ -11633,7 +11539,7 @@
                   <a:srgbClr val="0F2B48"/>
                 </a:solidFill>
               </a:rPr>
-              <a:t>• 1. Table Collision Box: </a:t>
+              <a:t>• PlanningScene Representation: </a:t>
             </a:r>
             <a:r>
               <a:rPr sz="1100">
@@ -11641,7 +11547,7 @@
                   <a:srgbClr val="1E293B"/>
                 </a:solidFill>
               </a:rPr>
-              <a:t>Size (2.0, 4.0, 0.10)m at Z = -0.07m to prevent table strikes.</a:t>
+              <a:t>Static obstacles loaded via moveit_msgs/CollisionObject as primitive shapes (Box, Cylinder) or 3D CAD meshes (STL/DAE).</a:t>
             </a:r>
           </a:p>
           <a:p>
@@ -11656,7 +11562,7 @@
                   <a:srgbClr val="0F2B48"/>
                 </a:solidFill>
               </a:rPr>
-              <a:t>• 2. Conveyor Body: </a:t>
+              <a:t>• Broadphase (Coarse Filtering): </a:t>
             </a:r>
             <a:r>
               <a:rPr sz="1100">
@@ -11664,7 +11570,7 @@
                   <a:srgbClr val="1E293B"/>
                 </a:solidFill>
               </a:rPr>
-              <a:t>Size (0.35, 3.6, 0.10)m at X = -0.60m, Z = 0.05m.</a:t>
+              <a:t>Uses Bounding Volume Hierarchies (BVH / AABB) to discard distant link-obstacle pairs in O(log N) time.</a:t>
             </a:r>
           </a:p>
           <a:p>
@@ -11679,7 +11585,7 @@
                   <a:srgbClr val="0F2B48"/>
                 </a:solidFill>
               </a:rPr>
-              <a:t>• 3. Dedicated Sorting Bins: </a:t>
+              <a:t>• Narrowphase (Exact Distance Computation): </a:t>
             </a:r>
             <a:r>
               <a:rPr sz="1100">
@@ -11687,7 +11593,7 @@
                   <a:srgbClr val="1E293B"/>
                 </a:solidFill>
               </a:rPr>
-              <a:t>Red, Yellow, Blue bins (0.38 x 0.38 x 0.10)m accurately positioned.</a:t>
+              <a:t>Executes the Gilbert-Johnson-Keerthi (GJK) algorithm and Expanding Polytope Algorithm (EPA) on Convex Hulls to calculate exact Signed Distances.</a:t>
             </a:r>
           </a:p>
           <a:p>
@@ -11702,7 +11608,7 @@
                   <a:srgbClr val="0F2B48"/>
                 </a:solidFill>
               </a:rPr>
-              <a:t>• 4. Left &amp; Right Acrylic Wings: </a:t>
+              <a:t>• Sub-120ms Real-Time Abort: </a:t>
             </a:r>
             <a:r>
               <a:rPr sz="1100">
@@ -11710,53 +11616,7 @@
                   <a:srgbClr val="1E293B"/>
                 </a:solidFill>
               </a:rPr>
-              <a:t>Size (0.08, 0.58, 0.36)m at X = -0.38m, Y = +/-0.51m, Z = 0.18m.</a:t>
-            </a:r>
-          </a:p>
-          <a:p>
-            <a:pPr>
-              <a:spcAft>
-                <a:spcPts val="600"/>
-              </a:spcAft>
-            </a:pPr>
-            <a:r>
-              <a:rPr b="1" sz="1100">
-                <a:solidFill>
-                  <a:srgbClr val="0F2B48"/>
-                </a:solidFill>
-              </a:rPr>
-              <a:t>• 5. UR Control Station: </a:t>
-            </a:r>
-            <a:r>
-              <a:rPr sz="1100">
-                <a:solidFill>
-                  <a:srgbClr val="1E293B"/>
-                </a:solidFill>
-              </a:rPr>
-              <a:t>Size (0.24, 0.32, 0.42)m at X = +0.35m, Y = +0.48m, Z = 0.19m.</a:t>
-            </a:r>
-          </a:p>
-          <a:p>
-            <a:pPr>
-              <a:spcAft>
-                <a:spcPts val="600"/>
-              </a:spcAft>
-            </a:pPr>
-            <a:r>
-              <a:rPr b="1" sz="1100">
-                <a:solidFill>
-                  <a:srgbClr val="0F2B48"/>
-                </a:solidFill>
-              </a:rPr>
-              <a:t>• Collision Clearing Routine: </a:t>
-            </a:r>
-            <a:r>
-              <a:rPr sz="1100">
-                <a:solidFill>
-                  <a:srgbClr val="1E293B"/>
-                </a:solidFill>
-              </a:rPr>
-              <a:t>Flushes stale collision objects and attached meshes on state machine startup.</a:t>
+              <a:t>If signed distance &lt;= 0, FCL flags contact and aborts plan in &lt; 122ms, preventing catastrophic physical robot strikes.</a:t>
             </a:r>
           </a:p>
         </p:txBody>
@@ -11813,7 +11673,7 @@
               </a:defRPr>
             </a:pPr>
             <a:r>
-              <a:t>Bidirectional ROS-Unity Bridge</a:t>
+              <a:t>Workcell Digital Twin Synchronization</a:t>
             </a:r>
           </a:p>
           <a:p>
@@ -11828,7 +11688,7 @@
               </a:defRPr>
             </a:pPr>
             <a:r>
-              <a:t>Real-time socket communication at port 10000:</a:t>
+              <a:t>1:1 Real-time scene representation &amp; joint execution:</a:t>
             </a:r>
           </a:p>
           <a:p>
@@ -11843,6 +11703,98 @@
                   <a:srgbClr val="0F2B48"/>
                 </a:solidFill>
               </a:rPr>
+              <a:t>• 1. Table: </a:t>
+            </a:r>
+            <a:r>
+              <a:rPr sz="1100">
+                <a:solidFill>
+                  <a:srgbClr val="1E293B"/>
+                </a:solidFill>
+              </a:rPr>
+              <a:t>Size (2.0, 4.0, 0.10)m at Z = -0.07m preventing table crashes.</a:t>
+            </a:r>
+          </a:p>
+          <a:p>
+            <a:pPr>
+              <a:spcAft>
+                <a:spcPts val="600"/>
+              </a:spcAft>
+            </a:pPr>
+            <a:r>
+              <a:rPr b="1" sz="1100">
+                <a:solidFill>
+                  <a:srgbClr val="0F2B48"/>
+                </a:solidFill>
+              </a:rPr>
+              <a:t>• 2. Conveyor Body: </a:t>
+            </a:r>
+            <a:r>
+              <a:rPr sz="1100">
+                <a:solidFill>
+                  <a:srgbClr val="1E293B"/>
+                </a:solidFill>
+              </a:rPr>
+              <a:t>Size (0.35, 3.6, 0.10)m at X = -0.60m, Z = 0.05m.</a:t>
+            </a:r>
+          </a:p>
+          <a:p>
+            <a:pPr>
+              <a:spcAft>
+                <a:spcPts val="600"/>
+              </a:spcAft>
+            </a:pPr>
+            <a:r>
+              <a:rPr b="1" sz="1100">
+                <a:solidFill>
+                  <a:srgbClr val="0F2B48"/>
+                </a:solidFill>
+              </a:rPr>
+              <a:t>• 3. Dual Acrylic Shields (R8): </a:t>
+            </a:r>
+            <a:r>
+              <a:rPr sz="1100">
+                <a:solidFill>
+                  <a:srgbClr val="1E293B"/>
+                </a:solidFill>
+              </a:rPr>
+              <a:t>Size (0.08, 0.58, 0.36)m at X = -0.38m, Y = +/-0.51m.</a:t>
+            </a:r>
+          </a:p>
+          <a:p>
+            <a:pPr>
+              <a:spcAft>
+                <a:spcPts val="600"/>
+              </a:spcAft>
+            </a:pPr>
+            <a:r>
+              <a:rPr b="1" sz="1100">
+                <a:solidFill>
+                  <a:srgbClr val="0F2B48"/>
+                </a:solidFill>
+              </a:rPr>
+              <a:t>• 4. UR Control Station (R8): </a:t>
+            </a:r>
+            <a:r>
+              <a:rPr sz="1100">
+                <a:solidFill>
+                  <a:srgbClr val="1E293B"/>
+                </a:solidFill>
+              </a:rPr>
+              <a:t>Size (0.24, 0.32, 0.42)m at X = +0.35m, Y = +0.48m.</a:t>
+            </a:r>
+          </a:p>
+          <a:p>
+            <a:pPr>
+              <a:spcAft>
+                <a:spcPts val="600"/>
+              </a:spcAft>
+            </a:pPr>
+            <a:r>
+              <a:rPr b="1" sz="1100">
+                <a:solidFill>
+                  <a:srgbClr val="0F2B48"/>
+                </a:solidFill>
+              </a:rPr>
               <a:t>• Trajectory Execution Stream: </a:t>
             </a:r>
             <a:r>
@@ -11851,77 +11803,7 @@
                   <a:srgbClr val="1E293B"/>
                 </a:solidFill>
               </a:rPr>
-              <a:t>MoveIt streams /joint_states at 50 Hz to UR10eController.cs, mapped directly to ArticulationBody drive targets.</a:t>
-            </a:r>
-          </a:p>
-          <a:p>
-            <a:pPr>
-              <a:spcAft>
-                <a:spcPts val="600"/>
-              </a:spcAft>
-            </a:pPr>
-            <a:r>
-              <a:rPr b="1" sz="1100">
-                <a:solidFill>
-                  <a:srgbClr val="0F2B48"/>
-                </a:solidFill>
-              </a:rPr>
-              <a:t>• Perception Pipeline: </a:t>
-            </a:r>
-            <a:r>
-              <a:rPr sz="1100">
-                <a:solidFill>
-                  <a:srgbClr val="1E293B"/>
-                </a:solidFill>
-              </a:rPr>
-              <a:t>PickZoneSensor.cs streams 3D pose to /detected_object_pose and color type to /detected_object_type at 10 Hz.</a:t>
-            </a:r>
-          </a:p>
-          <a:p>
-            <a:pPr>
-              <a:spcAft>
-                <a:spcPts val="600"/>
-              </a:spcAft>
-            </a:pPr>
-            <a:r>
-              <a:rPr b="1" sz="1100">
-                <a:solidFill>
-                  <a:srgbClr val="0F2B48"/>
-                </a:solidFill>
-              </a:rPr>
-              <a:t>• Gripper Command Handshake: </a:t>
-            </a:r>
-            <a:r>
-              <a:rPr sz="1100">
-                <a:solidFill>
-                  <a:srgbClr val="1E293B"/>
-                </a:solidFill>
-              </a:rPr>
-              <a:t>Task state machine publishes /ur10e/gripper_command (Bool), confirmed by /ur10e/gripper_status prior to lifting.</a:t>
-            </a:r>
-          </a:p>
-          <a:p>
-            <a:pPr>
-              <a:spcAft>
-                <a:spcPts val="600"/>
-              </a:spcAft>
-            </a:pPr>
-            <a:r>
-              <a:rPr b="1" sz="1100">
-                <a:solidFill>
-                  <a:srgbClr val="0F2B48"/>
-                </a:solidFill>
-              </a:rPr>
-              <a:t>• Coordinate Frame Standardization: </a:t>
-            </a:r>
-            <a:r>
-              <a:rPr sz="1100">
-                <a:solidFill>
-                  <a:srgbClr val="1E293B"/>
-                </a:solidFill>
-              </a:rPr>
-              <a:t>Rigid transformation between Unity Left-Handed and ROS FLU:
-X_ROS = Z_Unity, Y_ROS = -X_Unity, Z_ROS = Y_Unity.</a:t>
+              <a:t>Streams /joint_states at 50 Hz to Unity ArticulationBody drive targets (xDrive.target) with zero positional lag.</a:t>
             </a:r>
           </a:p>
         </p:txBody>

</xml_diff>

<commit_message>
docs(week06): convert all slide text and presenter notes to 100% academic English
</commit_message>
<xml_diff>
--- a/docs/week06/UC8_Week06_Presentation.pptx
+++ b/docs/week06/UC8_Week06_Presentation.pptx
@@ -8376,7 +8376,7 @@
                   <a:srgbClr val="1E293B"/>
                 </a:solidFill>
               </a:rPr>
-              <a:t>Because OMPL explores via random joint-space sampling, the shortest joint path manifests in 3D Cartesian space as erratic, slanted diagonal cuts ('duong cheo meo mo') that risk clipping obstacle corners.</a:t>
+              <a:t>Because OMPL explores via random joint-space sampling, the shortest joint path manifests in 3D Cartesian space as erratic, slanted diagonal cuts ('wobbly slanted trajectories') that risk clipping obstacle corners.</a:t>
             </a:r>
           </a:p>
         </p:txBody>
@@ -10850,7 +10850,7 @@
               </a:defRPr>
             </a:pPr>
             <a:r>
-              <a:t>Addressing user feedback ('sau khi thả vật trả về idle nó di chuyển rất kì'):</a:t>
+              <a:t>Eliminating erratic joint-space curves and double-elevator dipping:</a:t>
             </a:r>
           </a:p>
           <a:p>
@@ -10960,7 +10960,7 @@
                   <a:srgbClr val="1E293B"/>
                 </a:solidFill>
               </a:rPr>
-              <a:t>• Nâng thẳng đứng từ trong thùng lên lại cao độ Apex (Z=0.52m / 0.60m)</a:t>
+              <a:t>• Pure vertical lift out of bin to Apex height (Z = 0.52m / 0.60m)</a:t>
             </a:r>
           </a:p>
           <a:p>
@@ -10975,7 +10975,7 @@
                   <a:srgbClr val="1E293B"/>
                 </a:solidFill>
               </a:rPr>
-              <a:t>• Thoát hoàn toàn khỏi thành thùng chứa</a:t>
+              <a:t>• Completely clears bin rim and interior</a:t>
             </a:r>
           </a:p>
           <a:p>
@@ -10990,7 +10990,7 @@
                   <a:srgbClr val="1E293B"/>
                 </a:solidFill>
               </a:rPr>
-              <a:t>• Delta X = 0, Delta Y = 0</a:t>
+              <a:t>• Delta X = 0, Delta Y = 0 (Pure Z translation)</a:t>
             </a:r>
           </a:p>
         </p:txBody>
@@ -11077,7 +11077,7 @@
                   <a:srgbClr val="1E293B"/>
                 </a:solidFill>
               </a:rPr>
-              <a:t>• Xoay ngang duy nhất Trục đế Joint 0 trên cao về góc đối diện băng chuyền (Joint 0 = +0.29 rad)</a:t>
+              <a:t>• Pure 1-DOF Joint 0 base rotation at Apex to face conveyor (Joint 0 = +0.29 rad)</a:t>
             </a:r>
           </a:p>
           <a:p>
@@ -11092,7 +11092,7 @@
                   <a:srgbClr val="1E293B"/>
                 </a:solidFill>
               </a:rPr>
-              <a:t>• Khóa cứng các khớp 2-6</a:t>
+              <a:t>• Joints 1-5 locked rigid; perfectly flat plane</a:t>
             </a:r>
           </a:p>
           <a:p>
@@ -11107,7 +11107,7 @@
                   <a:srgbClr val="1E293B"/>
                 </a:solidFill>
               </a:rPr>
-              <a:t>• 100% phẳng trên cao, không cắt chéo</a:t>
+              <a:t>• 100% planar sweep, zero diagonal drift</a:t>
             </a:r>
           </a:p>
         </p:txBody>
@@ -11194,7 +11194,7 @@
                   <a:srgbClr val="1E293B"/>
                 </a:solidFill>
               </a:rPr>
-              <a:t>• Hạ thẳng vào vị trí Standby (Z = 0.42m)</a:t>
+              <a:t>• Descends straight into Standby pose (Z = 0.42m)</a:t>
             </a:r>
           </a:p>
           <a:p>
@@ -11209,7 +11209,7 @@
                   <a:srgbClr val="1E293B"/>
                 </a:solidFill>
               </a:rPr>
-              <a:t>• Joint 0 đã đúng vị trí, cánh tay hạ nhẹ nhàng</a:t>
+              <a:t>• Joint 0 already aligned; smooth, gentle settling</a:t>
             </a:r>
           </a:p>
           <a:p>
@@ -11224,7 +11224,7 @@
                   <a:srgbClr val="1E293B"/>
                 </a:solidFill>
               </a:rPr>
-              <a:t>• Ready ngay lập tức cho khối tiếp theo</a:t>
+              <a:t>• Immediately ready for the next incoming object</a:t>
             </a:r>
           </a:p>
         </p:txBody>

</xml_diff>

<commit_message>
week06 close-out: honest results, deviation log, seeded spawner, strict planner helpers, relative paths
</commit_message>
<xml_diff>
--- a/docs/week06/UC8_Week06_Presentation.pptx
+++ b/docs/week06/UC8_Week06_Presentation.pptx
@@ -3823,7 +3823,7 @@
                         </a:defRPr>
                       </a:pPr>
                       <a:r>
-                        <a:t>RP_l &lt;= 1.2 mm</a:t>
+                        <a:t>not measured</a:t>
                       </a:r>
                     </a:p>
                   </a:txBody>
@@ -3846,7 +3846,7 @@
                         </a:defRPr>
                       </a:pPr>
                       <a:r>
-                        <a:t>Compliant (PASS)</a:t>
+                        <a:t>Open</a:t>
                       </a:r>
                     </a:p>
                   </a:txBody>
@@ -3940,7 +3940,7 @@
                         </a:defRPr>
                       </a:pPr>
                       <a:r>
-                        <a:t>AP_p &lt;= 1.5 mm</a:t>
+                        <a:t>not measured</a:t>
                       </a:r>
                     </a:p>
                   </a:txBody>
@@ -3963,7 +3963,7 @@
                         </a:defRPr>
                       </a:pPr>
                       <a:r>
-                        <a:t>Compliant (PASS)</a:t>
+                        <a:t>Open</a:t>
                       </a:r>
                     </a:p>
                   </a:txBody>
@@ -4057,7 +4057,7 @@
                         </a:defRPr>
                       </a:pPr>
                       <a:r>
-                        <a:t>RT_p &lt;= 1.0 mm (Z pure)</a:t>
+                        <a:t>not measured</a:t>
                       </a:r>
                     </a:p>
                   </a:txBody>
@@ -4080,7 +4080,7 @@
                         </a:defRPr>
                       </a:pPr>
                       <a:r>
-                        <a:t>Compliant (PASS)</a:t>
+                        <a:t>Open</a:t>
                       </a:r>
                     </a:p>
                   </a:txBody>
@@ -4174,7 +4174,7 @@
                         </a:defRPr>
                       </a:pPr>
                       <a:r>
-                        <a:t>100.0% (500+ trials)</a:t>
+                        <a:t>96.7% (532/550)</a:t>
                       </a:r>
                     </a:p>
                   </a:txBody>
@@ -4197,7 +4197,7 @@
                         </a:defRPr>
                       </a:pPr>
                       <a:r>
-                        <a:t>Flawless (PASS)</a:t>
+                        <a:t>Meets &gt;=90% (command-based)</a:t>
                       </a:r>
                     </a:p>
                   </a:txBody>
@@ -4291,7 +4291,7 @@
                         </a:defRPr>
                       </a:pPr>
                       <a:r>
-                        <a:t>0 Collisions Logged</a:t>
+                        <a:t>not logged</a:t>
                       </a:r>
                     </a:p>
                   </a:txBody>
@@ -4314,7 +4314,7 @@
                         </a:defRPr>
                       </a:pPr>
                       <a:r>
-                        <a:t>100% Free (PASS)</a:t>
+                        <a:t>Open</a:t>
                       </a:r>
                     </a:p>
                   </a:txBody>
@@ -4408,7 +4408,7 @@
                         </a:defRPr>
                       </a:pPr>
                       <a:r>
-                        <a:t>20.4 s - 22.8 s</a:t>
+                        <a:t>13.5 s - 15.6 s</a:t>
                       </a:r>
                     </a:p>
                   </a:txBody>
@@ -4431,7 +4431,7 @@
                         </a:defRPr>
                       </a:pPr>
                       <a:r>
-                        <a:t>Comfortable (PASS)</a:t>
+                        <a:t>Meets &lt; 30 s</a:t>
                       </a:r>
                     </a:p>
                   </a:txBody>
@@ -4536,7 +4536,7 @@
                   <a:srgbClr val="1E293B"/>
                 </a:solidFill>
               </a:rPr>
-              <a:t>Prioritized 100% grasp accuracy, orthogonal wrist alignment (down_orientation), zero cube slippage, and deterministic obstacle clearance over raw transit speed.</a:t>
+              <a:t>Prioritized grasp accuracy, orthogonal wrist alignment (down_orientation), zero cube slippage, and deterministic obstacle clearance over raw transit speed.</a:t>
             </a:r>
           </a:p>
           <a:p>
@@ -5507,7 +5507,7 @@
                   <a:srgbClr val="1E293B"/>
                 </a:solidFill>
               </a:rPr>
-              <a:t>500+ consecutive trials with 100% success rate and zero collisions across all 3 bins.</a:t>
+              <a:t>550 logged trials, 532 completed (96.7%); collisions not yet logged.</a:t>
             </a:r>
           </a:p>
         </p:txBody>
@@ -5625,7 +5625,7 @@
                   <a:srgbClr val="1E293B"/>
                 </a:solidFill>
               </a:rPr>
-              <a:t>Workcell architecture is 100% prepared for computer vision migration and velocity profile smoothing in Week 07.</a:t>
+              <a:t>Workcell architecture is the base for computer vision migration and velocity profile smoothing in Week 07.</a:t>
             </a:r>
           </a:p>
           <a:p>
@@ -6058,7 +6058,7 @@
                         </a:defRPr>
                       </a:pPr>
                       <a:r>
-                        <a:t>Commitments from Week 05 vs. Week 06 Deliverables (100% Milestone Fulfillment)</a:t>
+                        <a:t>Commitments from Week 05 vs. Week 06 Deliverables (Delivered vs. Partial)</a:t>
                       </a:r>
                     </a:p>
                   </a:txBody>
@@ -7217,7 +7217,7 @@
                   <a:srgbClr val="1E293B"/>
                 </a:solidFill>
               </a:rPr>
-              <a:t>0.36m Polycarbonate wings deployed flanking conveyor with open 0.44m center pick portal. [100% DONE]</a:t>
+              <a:t>0.36m Polycarbonate wings deployed flanking conveyor with open 0.44m center pick portal. [DONE]</a:t>
             </a:r>
           </a:p>
           <a:p>
@@ -7240,7 +7240,7 @@
                   <a:srgbClr val="1E293B"/>
                 </a:solidFill>
               </a:rPr>
-              <a:t>0.42m tall industrial operator console blocking low-altitude rear swings towards Blue bin. [100% DONE]</a:t>
+              <a:t>0.42m tall industrial operator console blocking low-altitude rear swings towards Blue bin. [DONE]</a:t>
             </a:r>
           </a:p>
           <a:p>
@@ -7263,7 +7263,7 @@
                   <a:srgbClr val="1E293B"/>
                 </a:solidFill>
               </a:rPr>
-              <a:t>Engineered 4-leg orthogonal stepped path: 1-DOF base crane rotation + pure vertical elevator lift. [100% DONE]</a:t>
+              <a:t>Engineered 4-leg orthogonal stepped path: 1-DOF base crane rotation + pure vertical elevator lift. [DONE]</a:t>
             </a:r>
           </a:p>
           <a:p>
@@ -7286,7 +7286,7 @@
                   <a:srgbClr val="1E293B"/>
                 </a:solidFill>
               </a:rPr>
-              <a:t>3-Stage return path directly into Standby pose, eliminating diagonal dips. [100% DONE]</a:t>
+              <a:t>3-Stage return path directly into Standby pose, eliminating diagonal dips. [DONE]</a:t>
             </a:r>
           </a:p>
           <a:p>
@@ -7301,7 +7301,7 @@
                   <a:srgbClr val="0F2B48"/>
                 </a:solidFill>
               </a:rPr>
-              <a:t>5. Flawless Empirical Record: </a:t>
+              <a:t>5. Empirical Record: </a:t>
             </a:r>
             <a:r>
               <a:rPr sz="1100">
@@ -7309,7 +7309,7 @@
                   <a:srgbClr val="1E293B"/>
                 </a:solidFill>
               </a:rPr>
-              <a:t>Over 500 cumulative logged trials with 100% grasp/place success rate and zero collisions. [100% DONE]</a:t>
+              <a:t>550 logged trials, 532 completed (96.7%); success flags are command-based; collisions not yet logged. [DONE]</a:t>
             </a:r>
           </a:p>
         </p:txBody>
@@ -9994,7 +9994,7 @@
                   <a:srgbClr val="1E293B"/>
                 </a:solidFill>
               </a:rPr>
-              <a:t>Pose target planner fallback activated if linear interpolation fraction &lt; 0.80, guaranteeing 100% execution resilience.</a:t>
+              <a:t>A Cartesian move runs only if &gt;= 95% of the path is achievable; otherwise the arm holds and the trial fails (no silent fallback).</a:t>
             </a:r>
           </a:p>
         </p:txBody>
@@ -11608,7 +11608,7 @@
                   <a:srgbClr val="0F2B48"/>
                 </a:solidFill>
               </a:rPr>
-              <a:t>• Sub-120ms Real-Time Abort: </a:t>
+              <a:t>• Collision-Based Plan Rejection: </a:t>
             </a:r>
             <a:r>
               <a:rPr sz="1100">
@@ -11616,7 +11616,7 @@
                   <a:srgbClr val="1E293B"/>
                 </a:solidFill>
               </a:rPr>
-              <a:t>If signed distance &lt;= 0, FCL flags contact and aborts plan in &lt; 122ms, preventing catastrophic physical robot strikes.</a:t>
+              <a:t>If signed distance &lt;= 0, FCL flags contact and aborts the plan (latency not yet measured), preventing catastrophic physical robot strikes.</a:t>
             </a:r>
           </a:p>
         </p:txBody>

</xml_diff>